<commit_message>
report: change main point in slides
</commit_message>
<xml_diff>
--- a/report/slides.pptx
+++ b/report/slides.pptx
@@ -9162,7 +9162,7 @@
                 <a:ea typeface="Cambria" pitchFamily="34" charset="-122"/>
                 <a:cs typeface="Cambria" pitchFamily="34" charset="-120"/>
               </a:rPr>
-              <a:t>The Finding That Mattered Most</a:t>
+              <a:t>Both Fixes Need a Second Guard</a:t>
             </a:r>
             <a:endParaRPr lang="en-US" sz="3000" dirty="0"/>
           </a:p>
@@ -9201,7 +9201,7 @@
                 <a:ea typeface="Calibri" pitchFamily="34" charset="-122"/>
                 <a:cs typeface="Calibri" pitchFamily="34" charset="-120"/>
               </a:rPr>
-              <a:t>Gap-only γ selection doesn’t repair negation understanding — it collapses the space.</a:t>
+              <a:t>Maximizing the target metric alone finds the same degenerate optimum in either intervention.</a:t>
             </a:r>
             <a:endParaRPr lang="en-US" sz="1500" dirty="0"/>
           </a:p>
@@ -9261,13 +9261,13 @@
             <a:r>
               <a:rPr lang="en-US" sz="1300" b="1" spc="200" kern="0" dirty="0">
                 <a:solidFill>
-                  <a:srgbClr val="D64550"/>
+                  <a:srgbClr val="E3A54B"/>
                 </a:solidFill>
                 <a:latin typeface="Calibri" pitchFamily="34" charset="0"/>
                 <a:ea typeface="Calibri" pitchFamily="34" charset="-122"/>
                 <a:cs typeface="Calibri" pitchFamily="34" charset="-120"/>
               </a:rPr>
-              <a:t>UNCONSTRAINED</a:t>
+              <a:t>PROJECTION — γ</a:t>
             </a:r>
             <a:endParaRPr lang="en-US" sz="1300" dirty="0"/>
           </a:p>
@@ -9423,7 +9423,7 @@
                 <a:ea typeface="Calibri" pitchFamily="34" charset="-122"/>
                 <a:cs typeface="Calibri" pitchFamily="34" charset="-120"/>
               </a:rPr>
-              <a:t>almost every sentence looks alike — gap “opens” for free</a:t>
+              <a:t>guarded (γ = 12): sim_unrelated 0.350</a:t>
             </a:r>
             <a:endParaRPr lang="en-US" sz="1150" dirty="0"/>
           </a:p>
@@ -9483,13 +9483,13 @@
             <a:r>
               <a:rPr lang="en-US" sz="1300" b="1" spc="200" kern="0" dirty="0">
                 <a:solidFill>
-                  <a:srgbClr val="3E8E6A"/>
+                  <a:srgbClr val="E3A54B"/>
                 </a:solidFill>
                 <a:latin typeface="Calibri" pitchFamily="34" charset="0"/>
                 <a:ea typeface="Calibri" pitchFamily="34" charset="-122"/>
                 <a:cs typeface="Calibri" pitchFamily="34" charset="-120"/>
               </a:rPr>
-              <a:t>CONSTRAINED (≤ 0.5)</a:t>
+              <a:t>NLI_RERANK — λ</a:t>
             </a:r>
             <a:endParaRPr lang="en-US" sz="1300" dirty="0"/>
           </a:p>
@@ -9528,7 +9528,7 @@
                 <a:ea typeface="Cambria" pitchFamily="34" charset="-122"/>
                 <a:cs typeface="Cambria" pitchFamily="34" charset="-120"/>
               </a:rPr>
-              <a:t>γ = 12</a:t>
+              <a:t>λ = 1</a:t>
             </a:r>
             <a:endParaRPr lang="en-US" sz="3000" dirty="0"/>
           </a:p>
@@ -9567,7 +9567,7 @@
                 <a:ea typeface="Calibri" pitchFamily="34" charset="-122"/>
                 <a:cs typeface="Calibri" pitchFamily="34" charset="-120"/>
               </a:rPr>
-              <a:t>sim_unrelated</a:t>
+              <a:t>STS Spearman</a:t>
             </a:r>
             <a:endParaRPr lang="en-US" sz="1300" dirty="0"/>
           </a:p>
@@ -9600,13 +9600,13 @@
             <a:r>
               <a:rPr lang="en-US" sz="5200" b="1" dirty="0">
                 <a:solidFill>
-                  <a:srgbClr val="3E8E6A"/>
+                  <a:srgbClr val="D64550"/>
                 </a:solidFill>
                 <a:latin typeface="Cambria" pitchFamily="34" charset="0"/>
                 <a:ea typeface="Cambria" pitchFamily="34" charset="-122"/>
                 <a:cs typeface="Cambria" pitchFamily="34" charset="-120"/>
               </a:rPr>
-              <a:t>0.350</a:t>
+              <a:t>0.53</a:t>
             </a:r>
             <a:endParaRPr lang="en-US" sz="5200" dirty="0"/>
           </a:p>
@@ -9645,7 +9645,7 @@
                 <a:ea typeface="Calibri" pitchFamily="34" charset="-122"/>
                 <a:cs typeface="Calibri" pitchFamily="34" charset="-120"/>
               </a:rPr>
-              <a:t>healthy representation — the gap that remains is real</a:t>
+              <a:t>guarded (λ = 0.05–0.35): STS moves ≤ 0.07</a:t>
             </a:r>
             <a:endParaRPr lang="en-US" sz="1150" dirty="0"/>
           </a:p>
@@ -9684,7 +9684,7 @@
                 <a:ea typeface="Calibri" pitchFamily="34" charset="-122"/>
                 <a:cs typeface="Calibri" pitchFamily="34" charset="-120"/>
               </a:rPr>
-              <a:t>Held across every model &amp; direction estimator. Cross-validation did NOT catch it — collapse improves the metric on every fold.</a:t>
+              <a:t>Same fix either way: keep only the values an independent guard metric approves.</a:t>
             </a:r>
             <a:endParaRPr lang="en-US" sz="1300" dirty="0"/>
           </a:p>
@@ -9723,7 +9723,7 @@
                 <a:ea typeface="Calibri" pitchFamily="34" charset="-122"/>
                 <a:cs typeface="Calibri" pitchFamily="34" charset="-120"/>
               </a:rPr>
-              <a:t>multilingual-e5: no γ in the grid satisfies the constraint — reported as a negative result.</a:t>
+              <a:t>Held across all 4 models — the raw metric keeps “improving” right up to collapse.</a:t>
             </a:r>
             <a:endParaRPr lang="en-US" sz="1150" dirty="0"/>
           </a:p>

</xml_diff>

<commit_message>
report: fix stale projection accuracy numbers on slide 9
Slide 9's head-to-head chart still showed the pre-F5 projection accuracy
numbers (0.94/0.95/0.91/0.86) after the report's Table 6 was updated to the
best-by-accuracy config from the full 8-way ablation grid
(0.97/0.99/0.97/0.92). Updated both the chart's cached values and its
embedded worksheet so they stay in sync if reopened in PowerPoint. Also
export slides.pdf, since submission requires slides as PDF, not pptx.
</commit_message>
<xml_diff>
--- a/report/slides.pptx
+++ b/report/slides.pptx
@@ -900,16 +900,16 @@
                 <c:formatCode>General</c:formatCode>
                 <c:ptCount val="4"/>
                 <c:pt idx="0">
-                  <c:v>0.94</c:v>
+                  <c:v>0.97</c:v>
                 </c:pt>
                 <c:pt idx="1">
-                  <c:v>0.95</c:v>
+                  <c:v>0.99</c:v>
                 </c:pt>
                 <c:pt idx="2">
-                  <c:v>0.91</c:v>
+                  <c:v>0.97</c:v>
                 </c:pt>
                 <c:pt idx="3">
-                  <c:v>0.86</c:v>
+                  <c:v>0.92</c:v>
                 </c:pt>
               </c:numCache>
             </c:numRef>

</xml_diff>